<commit_message>
Revise template colors based on user feedback
- Nature: remove black background, use warm ivory + muted blue/gold
- Navy: change from medium blue to deep navy (#1A3A5C) + white + gold
- Slate: lighten the gray from #2C3E50 to #3D4F5F
- Teal: change from green to deep purple + pink (5B2C8E + CC79A7)
- Add .gitignore for samples/node_modules
- Update READMEs and sample generator

Co-Authored-By: Claude Opus 4.7 <noreply@anthropic.com>
</commit_message>
<xml_diff>
--- a/templates/samples/template_nature.pptx
+++ b/templates/samples/template_nature.pptx
@@ -1035,7 +1035,7 @@
     <p:bg>
       <p:bgPr>
         <a:solidFill>
-          <a:srgbClr val="0F0F1A"/>
+          <a:srgbClr val="F5F0E8"/>
         </a:solidFill>
       </p:bgPr>
     </p:bg>
@@ -1068,7 +1068,7 @@
             <a:avLst/>
           </a:prstGeom>
           <a:solidFill>
-            <a:srgbClr val="56B4E9"/>
+            <a:srgbClr val="4A6FA5"/>
           </a:solidFill>
           <a:ln/>
         </p:spPr>
@@ -1088,7 +1088,7 @@
             <a:avLst/>
           </a:prstGeom>
           <a:solidFill>
-            <a:srgbClr val="56B4E9"/>
+            <a:srgbClr val="4A6FA5"/>
           </a:solidFill>
           <a:ln/>
         </p:spPr>
@@ -1108,7 +1108,7 @@
             <a:avLst/>
           </a:prstGeom>
           <a:solidFill>
-            <a:srgbClr val="56B4E9"/>
+            <a:srgbClr val="4A6FA5"/>
           </a:solidFill>
           <a:ln/>
         </p:spPr>
@@ -1128,7 +1128,7 @@
             <a:avLst/>
           </a:prstGeom>
           <a:solidFill>
-            <a:srgbClr val="56B4E9"/>
+            <a:srgbClr val="4A6FA5"/>
           </a:solidFill>
           <a:ln/>
         </p:spPr>
@@ -1148,7 +1148,7 @@
             <a:avLst/>
           </a:prstGeom>
           <a:solidFill>
-            <a:srgbClr val="E69F00"/>
+            <a:srgbClr val="B8860B"/>
           </a:solidFill>
           <a:ln/>
         </p:spPr>
@@ -1180,7 +1180,7 @@
             <a:r>
               <a:rPr lang="en-US" sz="1300" dirty="0">
                 <a:solidFill>
-                  <a:srgbClr val="56B4E9"/>
+                  <a:srgbClr val="4A6FA5"/>
                 </a:solidFill>
                 <a:latin typeface="Arial" pitchFamily="34" charset="0"/>
                 <a:ea typeface="Arial" pitchFamily="34" charset="-122"/>
@@ -1219,7 +1219,7 @@
             <a:r>
               <a:rPr lang="en-US" sz="3200" b="1" dirty="0">
                 <a:solidFill>
-                  <a:srgbClr val="FFFFFF"/>
+                  <a:srgbClr val="2D2D2D"/>
                 </a:solidFill>
                 <a:latin typeface="Georgia" pitchFamily="34" charset="0"/>
                 <a:ea typeface="Georgia" pitchFamily="34" charset="-122"/>
@@ -1246,7 +1246,7 @@
             <a:avLst/>
           </a:prstGeom>
           <a:solidFill>
-            <a:srgbClr val="56B4E9"/>
+            <a:srgbClr val="4A6FA5"/>
           </a:solidFill>
           <a:ln/>
         </p:spPr>
@@ -1278,7 +1278,7 @@
             <a:r>
               <a:rPr lang="en-US" sz="1400" dirty="0">
                 <a:solidFill>
-                  <a:srgbClr val="9CA3AF"/>
+                  <a:srgbClr val="6B7280"/>
                 </a:solidFill>
                 <a:latin typeface="Arial" pitchFamily="34" charset="0"/>
                 <a:ea typeface="Arial" pitchFamily="34" charset="-122"/>
@@ -1320,7 +1320,7 @@
             <a:r>
               <a:rPr lang="en-US" sz="1200" dirty="0">
                 <a:solidFill>
-                  <a:srgbClr val="FFFFFF"/>
+                  <a:srgbClr val="2D2D2D"/>
                 </a:solidFill>
                 <a:latin typeface="Arial" pitchFamily="34" charset="0"/>
                 <a:ea typeface="Arial" pitchFamily="34" charset="-122"/>
@@ -1340,7 +1340,7 @@
             <a:r>
               <a:rPr lang="en-US" sz="1200" dirty="0">
                 <a:solidFill>
-                  <a:srgbClr val="FFFFFF"/>
+                  <a:srgbClr val="2D2D2D"/>
                 </a:solidFill>
                 <a:latin typeface="Arial" pitchFamily="34" charset="0"/>
                 <a:ea typeface="Arial" pitchFamily="34" charset="-122"/>
@@ -1360,7 +1360,7 @@
             <a:r>
               <a:rPr lang="en-US" sz="1200" dirty="0">
                 <a:solidFill>
-                  <a:srgbClr val="FFFFFF"/>
+                  <a:srgbClr val="2D2D2D"/>
                 </a:solidFill>
                 <a:latin typeface="Arial" pitchFamily="34" charset="0"/>
                 <a:ea typeface="Arial" pitchFamily="34" charset="-122"/>
@@ -1380,7 +1380,7 @@
             <a:r>
               <a:rPr lang="en-US" sz="1200" dirty="0">
                 <a:solidFill>
-                  <a:srgbClr val="FFFFFF"/>
+                  <a:srgbClr val="2D2D2D"/>
                 </a:solidFill>
                 <a:latin typeface="Arial" pitchFamily="34" charset="0"/>
                 <a:ea typeface="Arial" pitchFamily="34" charset="-122"/>
@@ -1407,7 +1407,7 @@
             <a:avLst/>
           </a:prstGeom>
           <a:solidFill>
-            <a:srgbClr val="E69F00"/>
+            <a:srgbClr val="B8860B"/>
           </a:solidFill>
           <a:ln/>
         </p:spPr>
@@ -1427,7 +1427,7 @@
             <a:avLst/>
           </a:prstGeom>
           <a:solidFill>
-            <a:srgbClr val="E69F00"/>
+            <a:srgbClr val="B8860B"/>
           </a:solidFill>
           <a:ln/>
         </p:spPr>
@@ -1447,7 +1447,7 @@
             <a:avLst/>
           </a:prstGeom>
           <a:solidFill>
-            <a:srgbClr val="E69F00"/>
+            <a:srgbClr val="B8860B"/>
           </a:solidFill>
           <a:ln/>
         </p:spPr>
@@ -1467,7 +1467,7 @@
             <a:avLst/>
           </a:prstGeom>
           <a:solidFill>
-            <a:srgbClr val="E69F00"/>
+            <a:srgbClr val="B8860B"/>
           </a:solidFill>
           <a:ln/>
         </p:spPr>
@@ -1499,7 +1499,7 @@
             <a:r>
               <a:rPr lang="en-US" sz="1100" dirty="0">
                 <a:solidFill>
-                  <a:srgbClr val="56B4E9"/>
+                  <a:srgbClr val="4A6FA5"/>
                 </a:solidFill>
                 <a:latin typeface="Arial" pitchFamily="34" charset="0"/>
                 <a:ea typeface="Arial" pitchFamily="34" charset="-122"/>
@@ -1558,7 +1558,7 @@
             <a:avLst/>
           </a:prstGeom>
           <a:solidFill>
-            <a:srgbClr val="56B4E9"/>
+            <a:srgbClr val="4A6FA5"/>
           </a:solidFill>
           <a:ln/>
         </p:spPr>
@@ -1578,7 +1578,7 @@
             <a:avLst/>
           </a:prstGeom>
           <a:solidFill>
-            <a:srgbClr val="E69F00"/>
+            <a:srgbClr val="B8860B"/>
           </a:solidFill>
           <a:ln/>
         </p:spPr>
@@ -1610,7 +1610,7 @@
             <a:r>
               <a:rPr lang="en-US" sz="2800" b="1" dirty="0">
                 <a:solidFill>
-                  <a:srgbClr val="0F0F1A"/>
+                  <a:srgbClr val="2D2D2D"/>
                 </a:solidFill>
                 <a:latin typeface="Georgia" pitchFamily="34" charset="0"/>
                 <a:ea typeface="Georgia" pitchFamily="34" charset="-122"/>
@@ -1712,7 +1712,7 @@
             <a:r>
               <a:rPr lang="en-US" sz="1800" dirty="0">
                 <a:solidFill>
-                  <a:srgbClr val="1F1F2E"/>
+                  <a:srgbClr val="2D2D2D"/>
                 </a:solidFill>
                 <a:latin typeface="Arial" pitchFamily="34" charset="0"/>
                 <a:ea typeface="Arial" pitchFamily="34" charset="-122"/>
@@ -1733,7 +1733,7 @@
             <a:r>
               <a:rPr lang="en-US" sz="1800" dirty="0">
                 <a:solidFill>
-                  <a:srgbClr val="1F1F2E"/>
+                  <a:srgbClr val="2D2D2D"/>
                 </a:solidFill>
                 <a:latin typeface="Arial" pitchFamily="34" charset="0"/>
                 <a:ea typeface="Arial" pitchFamily="34" charset="-122"/>
@@ -1754,7 +1754,7 @@
             <a:r>
               <a:rPr lang="en-US" sz="1800" dirty="0">
                 <a:solidFill>
-                  <a:srgbClr val="1F1F2E"/>
+                  <a:srgbClr val="2D2D2D"/>
                 </a:solidFill>
                 <a:latin typeface="Arial" pitchFamily="34" charset="0"/>
                 <a:ea typeface="Arial" pitchFamily="34" charset="-122"/>
@@ -1775,7 +1775,7 @@
             <a:r>
               <a:rPr lang="en-US" sz="1800" dirty="0">
                 <a:solidFill>
-                  <a:srgbClr val="1F1F2E"/>
+                  <a:srgbClr val="2D2D2D"/>
                 </a:solidFill>
                 <a:latin typeface="Arial" pitchFamily="34" charset="0"/>
                 <a:ea typeface="Arial" pitchFamily="34" charset="-122"/>
@@ -1804,11 +1804,11 @@
             </a:avLst>
           </a:prstGeom>
           <a:solidFill>
-            <a:srgbClr val="F0F4FF"/>
+            <a:srgbClr val="F5F0E8"/>
           </a:solidFill>
           <a:ln w="9525">
             <a:solidFill>
-              <a:srgbClr val="56B4E9"/>
+              <a:srgbClr val="B8860B"/>
             </a:solidFill>
             <a:prstDash val="solid"/>
           </a:ln>
@@ -1829,7 +1829,7 @@
             <a:avLst/>
           </a:prstGeom>
           <a:solidFill>
-            <a:srgbClr val="56B4E9"/>
+            <a:srgbClr val="4A6FA5"/>
           </a:solidFill>
           <a:ln/>
         </p:spPr>
@@ -1849,7 +1849,7 @@
             <a:avLst/>
           </a:prstGeom>
           <a:solidFill>
-            <a:srgbClr val="E69F00"/>
+            <a:srgbClr val="B8860B"/>
           </a:solidFill>
           <a:ln/>
         </p:spPr>
@@ -1881,7 +1881,7 @@
             <a:r>
               <a:rPr lang="en-US" sz="1600" dirty="0">
                 <a:solidFill>
-                  <a:srgbClr val="0F0F1A"/>
+                  <a:srgbClr val="2D2D2D"/>
                 </a:solidFill>
                 <a:latin typeface="Arial" pitchFamily="34" charset="0"/>
                 <a:ea typeface="Arial" pitchFamily="34" charset="-122"/>
@@ -1933,7 +1933,7 @@
             <a:avLst/>
           </a:prstGeom>
           <a:solidFill>
-            <a:srgbClr val="0F0F1A"/>
+            <a:srgbClr val="F5F0E8"/>
           </a:solidFill>
           <a:ln/>
         </p:spPr>
@@ -1953,7 +1953,7 @@
             <a:avLst/>
           </a:prstGeom>
           <a:solidFill>
-            <a:srgbClr val="56B4E9"/>
+            <a:srgbClr val="4A6FA5"/>
           </a:solidFill>
           <a:ln/>
         </p:spPr>
@@ -1973,7 +1973,7 @@
             <a:avLst/>
           </a:prstGeom>
           <a:solidFill>
-            <a:srgbClr val="E69F00"/>
+            <a:srgbClr val="B8860B"/>
           </a:solidFill>
           <a:ln/>
         </p:spPr>
@@ -1993,7 +1993,7 @@
             <a:avLst/>
           </a:prstGeom>
           <a:solidFill>
-            <a:srgbClr val="56B4E9"/>
+            <a:srgbClr val="4A6FA5"/>
           </a:solidFill>
           <a:ln/>
         </p:spPr>
@@ -2013,7 +2013,7 @@
             <a:avLst/>
           </a:prstGeom>
           <a:solidFill>
-            <a:srgbClr val="56B4E9"/>
+            <a:srgbClr val="4A6FA5"/>
           </a:solidFill>
           <a:ln/>
         </p:spPr>
@@ -2045,7 +2045,7 @@
             <a:r>
               <a:rPr lang="en-US" sz="2800" b="1" dirty="0">
                 <a:solidFill>
-                  <a:srgbClr val="FFFFFF"/>
+                  <a:srgbClr val="2D2D2D"/>
                 </a:solidFill>
                 <a:latin typeface="Georgia" pitchFamily="34" charset="0"/>
                 <a:ea typeface="Georgia" pitchFamily="34" charset="-122"/>
@@ -2087,7 +2087,7 @@
             <a:r>
               <a:rPr lang="en-US" sz="2200" dirty="0">
                 <a:solidFill>
-                  <a:srgbClr val="FFFFFF"/>
+                  <a:srgbClr val="2D2D2D"/>
                 </a:solidFill>
                 <a:latin typeface="Arial" pitchFamily="34" charset="0"/>
                 <a:ea typeface="Arial" pitchFamily="34" charset="-122"/>
@@ -2107,7 +2107,7 @@
             <a:r>
               <a:rPr lang="en-US" sz="2200" dirty="0">
                 <a:solidFill>
-                  <a:srgbClr val="FFFFFF"/>
+                  <a:srgbClr val="2D2D2D"/>
                 </a:solidFill>
                 <a:latin typeface="Arial" pitchFamily="34" charset="0"/>
                 <a:ea typeface="Arial" pitchFamily="34" charset="-122"/>
@@ -2127,7 +2127,7 @@
             <a:r>
               <a:rPr lang="en-US" sz="2200" dirty="0">
                 <a:solidFill>
-                  <a:srgbClr val="FFFFFF"/>
+                  <a:srgbClr val="2D2D2D"/>
                 </a:solidFill>
                 <a:latin typeface="Arial" pitchFamily="34" charset="0"/>
                 <a:ea typeface="Arial" pitchFamily="34" charset="-122"/>
@@ -2147,7 +2147,7 @@
             <a:r>
               <a:rPr lang="en-US" sz="2200" dirty="0">
                 <a:solidFill>
-                  <a:srgbClr val="FFFFFF"/>
+                  <a:srgbClr val="2D2D2D"/>
                 </a:solidFill>
                 <a:latin typeface="Arial" pitchFamily="34" charset="0"/>
                 <a:ea typeface="Arial" pitchFamily="34" charset="-122"/>
@@ -2167,7 +2167,7 @@
             <a:r>
               <a:rPr lang="en-US" sz="2200" dirty="0">
                 <a:solidFill>
-                  <a:srgbClr val="FFFFFF"/>
+                  <a:srgbClr val="2D2D2D"/>
                 </a:solidFill>
                 <a:latin typeface="Arial" pitchFamily="34" charset="0"/>
                 <a:ea typeface="Arial" pitchFamily="34" charset="-122"/>

</xml_diff>